<commit_message>
Add Team 11 details; full README generated from results; rebuild report and slides
Co-Authored-By: Claude Sonnet 5.5 <noreply@anthropic.com>
Claude-Session: https://claude.ai/code/session_012km1MXGk3VPHJprGNCE5s1
</commit_message>
<xml_diff>
--- a/report/Memory_Inspired_Chatbot_Slides.pptx
+++ b/report/Memory_Inspired_Chatbot_Slides.pptx
@@ -3211,7 +3211,7 @@
               </a:defRPr>
             </a:pPr>
             <a:r>
-              <a:t>IT 207 Human Intelligence project</a:t>
+              <a:t>IT 207 Human Intelligence project  |  Team 11  |  October 2026</a:t>
             </a:r>
           </a:p>
           <a:p>
@@ -3226,7 +3226,22 @@
               </a:defRPr>
             </a:pPr>
             <a:r>
-              <a:t>[Team members]  |  [Instructor]  |  October 2026</a:t>
+              <a:t>Yuvaraj S (251AI050), Abhinav Karthik Rao (251AI003), Mohammed Rayan (251AI025),</a:t>
+            </a:r>
+          </a:p>
+          <a:p>
+            <a:pPr>
+              <a:spcAft>
+                <a:spcPts val="600"/>
+              </a:spcAft>
+              <a:defRPr sz="1800" b="0">
+                <a:solidFill>
+                  <a:srgbClr val="555555"/>
+                </a:solidFill>
+              </a:defRPr>
+            </a:pPr>
+            <a:r>
+              <a:t>Mohammed Ayyoub (251AI026), Jayant Nenmeli (251AI022)</a:t>
             </a:r>
           </a:p>
         </p:txBody>

</xml_diff>